<commit_message>
Add page numbers to every PowerPoint; move slide answers off blank lines into empty space; add Claude skill package
- make_pptx.py and make_lesson_key.py add a bottom-right slide-number field to each slide
- Topic 2 slides with answers: fill-in answers now sit past the blanks (L1 s65, L2 s6, s7, s55),
  crowded answers moved below the questions (L1 s23, s53, L4 s18)
- Rebuilt all Topic 2 decks, IEP/504 versions, catch-ups, keys and assessment
- skill/: SKILL.md + add_answers.py; make_skill.py packages them with the converters into an uploadable zip

Co-Authored-By: Claude Opus 5.5 (1M context) <noreply@anthropic.com>
</commit_message>
<xml_diff>
--- a/IEP/Topic2-Assessment-IEP-ANSWER-KEY.pptx
+++ b/IEP/Topic2-Assessment-IEP-ANSWER-KEY.pptx
@@ -1064,6 +1064,40 @@
           </a:p>
         </p:txBody>
       </p:sp>
+      <p:sp>
+        <p:nvSpPr>
+          <p:cNvPr id="8" name="Slide Number 8"/>
+          <p:cNvSpPr txBox="1"/>
+          <p:nvPr/>
+        </p:nvSpPr>
+        <p:spPr>
+          <a:xfrm>
+            <a:off x="11277295" y="6611112"/>
+            <a:ext cx="685800" cy="201168"/>
+          </a:xfrm>
+          <a:prstGeom prst="rect">
+            <a:avLst/>
+          </a:prstGeom>
+          <a:noFill/>
+        </p:spPr>
+        <p:txBody>
+          <a:bodyPr wrap="none" lIns="0" tIns="0" rIns="0" bIns="0" anchor="b">
+            <a:noAutofit/>
+          </a:bodyPr>
+          <a:lstStyle/>
+          <a:p>
+            <a:pPr algn="r"/>
+            <a:fld id="{5C1A6E0B-3B1F-4D5E-9C7A-2F4B8D6E1A90}" type="slidenum">
+              <a:rPr lang="en-US" sz="1200" dirty="0">
+                <a:solidFill>
+                  <a:srgbClr val="5F6272"/>
+                </a:solidFill>
+              </a:rPr>
+              <a:t>1</a:t>
+            </a:fld>
+          </a:p>
+        </p:txBody>
+      </p:sp>
     </p:spTree>
   </p:cSld>
   <p:clrMapOvr>
@@ -2004,6 +2038,40 @@
           </a:p>
         </p:txBody>
       </p:sp>
+      <p:sp>
+        <p:nvSpPr>
+          <p:cNvPr id="24" name="Slide Number 24"/>
+          <p:cNvSpPr txBox="1"/>
+          <p:nvPr/>
+        </p:nvSpPr>
+        <p:spPr>
+          <a:xfrm>
+            <a:off x="11277295" y="6611112"/>
+            <a:ext cx="685800" cy="201168"/>
+          </a:xfrm>
+          <a:prstGeom prst="rect">
+            <a:avLst/>
+          </a:prstGeom>
+          <a:noFill/>
+        </p:spPr>
+        <p:txBody>
+          <a:bodyPr wrap="none" lIns="0" tIns="0" rIns="0" bIns="0" anchor="b">
+            <a:noAutofit/>
+          </a:bodyPr>
+          <a:lstStyle/>
+          <a:p>
+            <a:pPr algn="r"/>
+            <a:fld id="{5C1A6E0B-3B1F-4D5E-9C7A-2F4B8D6E1A90}" type="slidenum">
+              <a:rPr lang="en-US" sz="1200" dirty="0">
+                <a:solidFill>
+                  <a:srgbClr val="5F6272"/>
+                </a:solidFill>
+              </a:rPr>
+              <a:t>2</a:t>
+            </a:fld>
+          </a:p>
+        </p:txBody>
+      </p:sp>
     </p:spTree>
   </p:cSld>
   <p:clrMapOvr>
@@ -2963,6 +3031,40 @@
           </a:p>
         </p:txBody>
       </p:sp>
+      <p:sp>
+        <p:nvSpPr>
+          <p:cNvPr id="24" name="Slide Number 24"/>
+          <p:cNvSpPr txBox="1"/>
+          <p:nvPr/>
+        </p:nvSpPr>
+        <p:spPr>
+          <a:xfrm>
+            <a:off x="11277295" y="6611112"/>
+            <a:ext cx="685800" cy="201168"/>
+          </a:xfrm>
+          <a:prstGeom prst="rect">
+            <a:avLst/>
+          </a:prstGeom>
+          <a:noFill/>
+        </p:spPr>
+        <p:txBody>
+          <a:bodyPr wrap="none" lIns="0" tIns="0" rIns="0" bIns="0" anchor="b">
+            <a:noAutofit/>
+          </a:bodyPr>
+          <a:lstStyle/>
+          <a:p>
+            <a:pPr algn="r"/>
+            <a:fld id="{5C1A6E0B-3B1F-4D5E-9C7A-2F4B8D6E1A90}" type="slidenum">
+              <a:rPr lang="en-US" sz="1200" dirty="0">
+                <a:solidFill>
+                  <a:srgbClr val="5F6272"/>
+                </a:solidFill>
+              </a:rPr>
+              <a:t>3</a:t>
+            </a:fld>
+          </a:p>
+        </p:txBody>
+      </p:sp>
     </p:spTree>
   </p:cSld>
   <p:clrMapOvr>
@@ -3941,6 +4043,40 @@
           </a:p>
         </p:txBody>
       </p:sp>
+      <p:sp>
+        <p:nvSpPr>
+          <p:cNvPr id="24" name="Slide Number 24"/>
+          <p:cNvSpPr txBox="1"/>
+          <p:nvPr/>
+        </p:nvSpPr>
+        <p:spPr>
+          <a:xfrm>
+            <a:off x="11277295" y="6611112"/>
+            <a:ext cx="685800" cy="201168"/>
+          </a:xfrm>
+          <a:prstGeom prst="rect">
+            <a:avLst/>
+          </a:prstGeom>
+          <a:noFill/>
+        </p:spPr>
+        <p:txBody>
+          <a:bodyPr wrap="none" lIns="0" tIns="0" rIns="0" bIns="0" anchor="b">
+            <a:noAutofit/>
+          </a:bodyPr>
+          <a:lstStyle/>
+          <a:p>
+            <a:pPr algn="r"/>
+            <a:fld id="{5C1A6E0B-3B1F-4D5E-9C7A-2F4B8D6E1A90}" type="slidenum">
+              <a:rPr lang="en-US" sz="1200" dirty="0">
+                <a:solidFill>
+                  <a:srgbClr val="5F6272"/>
+                </a:solidFill>
+              </a:rPr>
+              <a:t>4</a:t>
+            </a:fld>
+          </a:p>
+        </p:txBody>
+      </p:sp>
     </p:spTree>
   </p:cSld>
   <p:clrMapOvr>
@@ -4536,6 +4672,40 @@
           </a:p>
         </p:txBody>
       </p:sp>
+      <p:sp>
+        <p:nvSpPr>
+          <p:cNvPr id="16" name="Slide Number 16"/>
+          <p:cNvSpPr txBox="1"/>
+          <p:nvPr/>
+        </p:nvSpPr>
+        <p:spPr>
+          <a:xfrm>
+            <a:off x="11277295" y="6611112"/>
+            <a:ext cx="685800" cy="201168"/>
+          </a:xfrm>
+          <a:prstGeom prst="rect">
+            <a:avLst/>
+          </a:prstGeom>
+          <a:noFill/>
+        </p:spPr>
+        <p:txBody>
+          <a:bodyPr wrap="none" lIns="0" tIns="0" rIns="0" bIns="0" anchor="b">
+            <a:noAutofit/>
+          </a:bodyPr>
+          <a:lstStyle/>
+          <a:p>
+            <a:pPr algn="r"/>
+            <a:fld id="{5C1A6E0B-3B1F-4D5E-9C7A-2F4B8D6E1A90}" type="slidenum">
+              <a:rPr lang="en-US" sz="1200" dirty="0">
+                <a:solidFill>
+                  <a:srgbClr val="5F6272"/>
+                </a:solidFill>
+              </a:rPr>
+              <a:t>5</a:t>
+            </a:fld>
+          </a:p>
+        </p:txBody>
+      </p:sp>
     </p:spTree>
   </p:cSld>
   <p:clrMapOvr>
@@ -4693,6 +4863,40 @@
               <a:t xml:space="preserve">Topic 2 Assessment · IEP Version · Answer Key (teacher copy)</a:t>
             </a:r>
             <a:endParaRPr lang="en-US" sz="1125" dirty="0"/>
+          </a:p>
+        </p:txBody>
+      </p:sp>
+      <p:sp>
+        <p:nvSpPr>
+          <p:cNvPr id="5" name="Slide Number 5"/>
+          <p:cNvSpPr txBox="1"/>
+          <p:nvPr/>
+        </p:nvSpPr>
+        <p:spPr>
+          <a:xfrm>
+            <a:off x="11277295" y="6611112"/>
+            <a:ext cx="685800" cy="201168"/>
+          </a:xfrm>
+          <a:prstGeom prst="rect">
+            <a:avLst/>
+          </a:prstGeom>
+          <a:noFill/>
+        </p:spPr>
+        <p:txBody>
+          <a:bodyPr wrap="none" lIns="0" tIns="0" rIns="0" bIns="0" anchor="b">
+            <a:noAutofit/>
+          </a:bodyPr>
+          <a:lstStyle/>
+          <a:p>
+            <a:pPr algn="r"/>
+            <a:fld id="{5C1A6E0B-3B1F-4D5E-9C7A-2F4B8D6E1A90}" type="slidenum">
+              <a:rPr lang="en-US" sz="1200" dirty="0">
+                <a:solidFill>
+                  <a:srgbClr val="5F6272"/>
+                </a:solidFill>
+              </a:rPr>
+              <a:t>6</a:t>
+            </a:fld>
           </a:p>
         </p:txBody>
       </p:sp>

</xml_diff>